<commit_message>
Las láminas de texto dicen de qué archivo salen sus ejemplos
Cada lámina que usa el corpus lleva ahora una línea al pie con el
archivo, la hoja y los folios, para que nadie tenga que acordarse de
dónde vienen los conteos y las citas. Aplica a las dos láminas nuevas
de la sesión 4, a la de recuperación de la sesión 5 y a cuatro del
anexo visual.

Co-Authored-By: Claude Opus 5 <noreply@anthropic.com>
</commit_message>
<xml_diff>
--- a/sesion-04/Anexo_De_las_palabras_a_los_numeros.pptx
+++ b/sesion-04/Anexo_De_las_palabras_a_los_numeros.pptx
@@ -1707,7 +1707,7 @@
         </p:nvSpPr>
         <p:spPr>
           <a:xfrm>
-            <a:off x="566928" y="5824728"/>
+            <a:off x="566928" y="5700000"/>
             <a:ext cx="11057839" cy="594360"/>
           </a:xfrm>
           <a:prstGeom prst="roundRect">
@@ -1734,7 +1734,7 @@
         </p:nvSpPr>
         <p:spPr>
           <a:xfrm>
-            <a:off x="804672" y="5824728"/>
+            <a:off x="804672" y="5700000"/>
             <a:ext cx="10582351" cy="594360"/>
           </a:xfrm>
           <a:prstGeom prst="rect">
@@ -2672,7 +2672,7 @@
         </p:nvSpPr>
         <p:spPr>
           <a:xfrm>
-            <a:off x="566928" y="5824728"/>
+            <a:off x="566928" y="5700000"/>
             <a:ext cx="11057839" cy="594360"/>
           </a:xfrm>
           <a:prstGeom prst="roundRect">
@@ -2699,7 +2699,7 @@
         </p:nvSpPr>
         <p:spPr>
           <a:xfrm>
-            <a:off x="804672" y="5824728"/>
+            <a:off x="804672" y="5700000"/>
             <a:ext cx="10582351" cy="594360"/>
           </a:xfrm>
           <a:prstGeom prst="rect">
@@ -2730,6 +2730,45 @@
               <a:t>No es un defecto del programa: es lo que pasa cuando cuentas sin pesar. La lámina que sigue es el arreglo.</a:t>
             </a:r>
             <a:endParaRPr lang="es-MX" sz="1300" dirty="0"/>
+          </a:p>
+        </p:txBody>
+      </p:sp>
+      <p:sp>
+        <p:nvSpPr>
+          <p:cNvPr id="27" name="Text"/>
+          <p:cNvSpPr txBox="1"/>
+          <p:nvPr/>
+        </p:nvSpPr>
+        <p:spPr>
+          <a:xfrm>
+            <a:off x="566928" y="6360000"/>
+            <a:ext cx="11057839" cy="240000"/>
+          </a:xfrm>
+          <a:prstGeom prst="rect">
+            <a:avLst/>
+          </a:prstGeom>
+          <a:noFill/>
+          <a:ln/>
+        </p:spPr>
+        <p:txBody>
+          <a:bodyPr wrap="square" lIns="0" tIns="0" rIns="0" bIns="0" rtlCol="0" anchor="t"/>
+          <a:lstStyle/>
+          <a:p>
+            <a:pPr indent="0" marL="0">
+              <a:buNone/>
+            </a:pPr>
+            <a:r>
+              <a:rPr lang="es-MX" sz="1000" dirty="0">
+                <a:solidFill>
+                  <a:srgbClr val="5A6B73"/>
+                </a:solidFill>
+                <a:latin typeface="Calibri" pitchFamily="34" charset="0"/>
+                <a:ea typeface="Calibri" pitchFamily="34" charset="-122"/>
+                <a:cs typeface="Calibri" pitchFamily="34" charset="-120"/>
+              </a:rPr>
+              <a:t>Ejemplos de tu propio corpus: Registros_atencion_ciudadana_PARTICIPANTE.xlsx, hoja Registros, los 118 registros de la Práctica C.</a:t>
+            </a:r>
+            <a:endParaRPr lang="es-MX" sz="1000" dirty="0"/>
           </a:p>
         </p:txBody>
       </p:sp>
@@ -4509,8 +4548,8 @@
         </p:nvSpPr>
         <p:spPr>
           <a:xfrm>
-            <a:off x="566928" y="5760000"/>
-            <a:ext cx="11057839" cy="680000"/>
+            <a:off x="566928" y="5660000"/>
+            <a:ext cx="11057839" cy="640000"/>
           </a:xfrm>
           <a:prstGeom prst="roundRect">
             <a:avLst>
@@ -4536,8 +4575,8 @@
         </p:nvSpPr>
         <p:spPr>
           <a:xfrm>
-            <a:off x="804672" y="5760000"/>
-            <a:ext cx="10582351" cy="680000"/>
+            <a:off x="804672" y="5660000"/>
+            <a:ext cx="10582351" cy="640000"/>
           </a:xfrm>
           <a:prstGeom prst="rect">
             <a:avLst/>
@@ -4567,6 +4606,45 @@
               <a:t>Cuidado con el otro lado de la misma moneda: una palabra rara pesa mucho, pero un tema del que solo hay dos o tres registros no junta casos suficientes para volverse categoría. Termina en «otros», y «otros» se revisa a mano.</a:t>
             </a:r>
             <a:endParaRPr lang="es-MX" sz="1300" dirty="0"/>
+          </a:p>
+        </p:txBody>
+      </p:sp>
+      <p:sp>
+        <p:nvSpPr>
+          <p:cNvPr id="53" name="Text"/>
+          <p:cNvSpPr txBox="1"/>
+          <p:nvPr/>
+        </p:nvSpPr>
+        <p:spPr>
+          <a:xfrm>
+            <a:off x="566928" y="6360000"/>
+            <a:ext cx="11057839" cy="240000"/>
+          </a:xfrm>
+          <a:prstGeom prst="rect">
+            <a:avLst/>
+          </a:prstGeom>
+          <a:noFill/>
+          <a:ln/>
+        </p:spPr>
+        <p:txBody>
+          <a:bodyPr wrap="square" lIns="0" tIns="0" rIns="0" bIns="0" rtlCol="0" anchor="t"/>
+          <a:lstStyle/>
+          <a:p>
+            <a:pPr indent="0" marL="0">
+              <a:buNone/>
+            </a:pPr>
+            <a:r>
+              <a:rPr lang="es-MX" sz="1000" dirty="0">
+                <a:solidFill>
+                  <a:srgbClr val="5A6B73"/>
+                </a:solidFill>
+                <a:latin typeface="Calibri" pitchFamily="34" charset="0"/>
+                <a:ea typeface="Calibri" pitchFamily="34" charset="-122"/>
+                <a:cs typeface="Calibri" pitchFamily="34" charset="-120"/>
+              </a:rPr>
+              <a:t>Ejemplos de tu propio corpus: Registros_atencion_ciudadana_PARTICIPANTE.xlsx, hoja Registros, los 118 registros de la Práctica C.</a:t>
+            </a:r>
+            <a:endParaRPr lang="es-MX" sz="1000" dirty="0"/>
           </a:p>
         </p:txBody>
       </p:sp>
@@ -5410,7 +5488,7 @@
         </p:nvSpPr>
         <p:spPr>
           <a:xfrm>
-            <a:off x="566928" y="5824728"/>
+            <a:off x="566928" y="5700000"/>
             <a:ext cx="11057839" cy="594360"/>
           </a:xfrm>
           <a:prstGeom prst="roundRect">
@@ -5437,7 +5515,7 @@
         </p:nvSpPr>
         <p:spPr>
           <a:xfrm>
-            <a:off x="804672" y="5824728"/>
+            <a:off x="804672" y="5700000"/>
             <a:ext cx="10582351" cy="594360"/>
           </a:xfrm>
           <a:prstGeom prst="rect">
@@ -5468,6 +5546,45 @@
               <a:t>Los dos errores cuestan igual: el primero junta lo que debía separarse y el segundo separa lo que debía juntarse. Por eso el agrupamiento se revisa a mano antes de reportar nada.</a:t>
             </a:r>
             <a:endParaRPr lang="es-MX" sz="1300" dirty="0"/>
+          </a:p>
+        </p:txBody>
+      </p:sp>
+      <p:sp>
+        <p:nvSpPr>
+          <p:cNvPr id="26" name="Text"/>
+          <p:cNvSpPr txBox="1"/>
+          <p:nvPr/>
+        </p:nvSpPr>
+        <p:spPr>
+          <a:xfrm>
+            <a:off x="566928" y="6360000"/>
+            <a:ext cx="11057839" cy="240000"/>
+          </a:xfrm>
+          <a:prstGeom prst="rect">
+            <a:avLst/>
+          </a:prstGeom>
+          <a:noFill/>
+          <a:ln/>
+        </p:spPr>
+        <p:txBody>
+          <a:bodyPr wrap="square" lIns="0" tIns="0" rIns="0" bIns="0" rtlCol="0" anchor="t"/>
+          <a:lstStyle/>
+          <a:p>
+            <a:pPr indent="0" marL="0">
+              <a:buNone/>
+            </a:pPr>
+            <a:r>
+              <a:rPr lang="es-MX" sz="1000" dirty="0">
+                <a:solidFill>
+                  <a:srgbClr val="5A6B73"/>
+                </a:solidFill>
+                <a:latin typeface="Calibri" pitchFamily="34" charset="0"/>
+                <a:ea typeface="Calibri" pitchFamily="34" charset="-122"/>
+                <a:cs typeface="Calibri" pitchFamily="34" charset="-120"/>
+              </a:rPr>
+              <a:t>De ese mismo archivo, hoja Registros: folios RAC-2025-00073, 00055, 00014 y 00096.</a:t>
+            </a:r>
+            <a:endParaRPr lang="es-MX" sz="1000" dirty="0"/>
           </a:p>
         </p:txBody>
       </p:sp>
@@ -6275,7 +6392,7 @@
         </p:nvSpPr>
         <p:spPr>
           <a:xfrm>
-            <a:off x="566928" y="5824728"/>
+            <a:off x="566928" y="5700000"/>
             <a:ext cx="11057839" cy="594360"/>
           </a:xfrm>
           <a:prstGeom prst="roundRect">
@@ -6302,7 +6419,7 @@
         </p:nvSpPr>
         <p:spPr>
           <a:xfrm>
-            <a:off x="804672" y="5824728"/>
+            <a:off x="804672" y="5700000"/>
             <a:ext cx="10582351" cy="594360"/>
           </a:xfrm>
           <a:prstGeom prst="rect">
@@ -6333,6 +6450,45 @@
               <a:t>Ese mapa tiene cientos de dimensiones, no dos. El dibujo es una simplificación: lo único que se conserva es qué queda cerca de qué.</a:t>
             </a:r>
             <a:endParaRPr lang="es-MX" sz="1300" dirty="0"/>
+          </a:p>
+        </p:txBody>
+      </p:sp>
+      <p:sp>
+        <p:nvSpPr>
+          <p:cNvPr id="27" name="Text"/>
+          <p:cNvSpPr txBox="1"/>
+          <p:nvPr/>
+        </p:nvSpPr>
+        <p:spPr>
+          <a:xfrm>
+            <a:off x="566928" y="6360000"/>
+            <a:ext cx="11057839" cy="240000"/>
+          </a:xfrm>
+          <a:prstGeom prst="rect">
+            <a:avLst/>
+          </a:prstGeom>
+          <a:noFill/>
+          <a:ln/>
+        </p:spPr>
+        <p:txBody>
+          <a:bodyPr wrap="square" lIns="0" tIns="0" rIns="0" bIns="0" rtlCol="0" anchor="t"/>
+          <a:lstStyle/>
+          <a:p>
+            <a:pPr indent="0" marL="0">
+              <a:buNone/>
+            </a:pPr>
+            <a:r>
+              <a:rPr lang="es-MX" sz="1000" dirty="0">
+                <a:solidFill>
+                  <a:srgbClr val="5A6B73"/>
+                </a:solidFill>
+                <a:latin typeface="Calibri" pitchFamily="34" charset="0"/>
+                <a:ea typeface="Calibri" pitchFamily="34" charset="-122"/>
+                <a:cs typeface="Calibri" pitchFamily="34" charset="-120"/>
+              </a:rPr>
+              <a:t>De ese mismo archivo, hoja Registros: folios RAC-2025-00073, 00055, 00014 y 00096.</a:t>
+            </a:r>
+            <a:endParaRPr lang="es-MX" sz="1000" dirty="0"/>
           </a:p>
         </p:txBody>
       </p:sp>
@@ -7030,7 +7186,7 @@
         </p:nvSpPr>
         <p:spPr>
           <a:xfrm>
-            <a:off x="566928" y="5824728"/>
+            <a:off x="566928" y="5700000"/>
             <a:ext cx="11057839" cy="594360"/>
           </a:xfrm>
           <a:prstGeom prst="roundRect">
@@ -7057,7 +7213,7 @@
         </p:nvSpPr>
         <p:spPr>
           <a:xfrm>
-            <a:off x="804672" y="5824728"/>
+            <a:off x="804672" y="5700000"/>
             <a:ext cx="10582351" cy="594360"/>
           </a:xfrm>
           <a:prstGeom prst="rect">

</xml_diff>